<commit_message>
Apply multi-perspective review fixes (P0/P1) and add full review report
- Fix three overclaims (demo results, AI confidentiality, purchase urging)
- Add small-company subsidy row, insurance-eligibility and cap notes, time-stamped info
- Add NotebookLM credit, voice-input / rate-limit / restroom / QR-prep guidance
- Unify note timecodes with script; rename checklist; expand ops checklist
- review-report.md: 4-reviewer parallel review + cross-review + panel discussion

Co-Authored-By: Claude Fable 5 <noreply@anthropic.com>
Claude-Session: https://claude.ai/code/session_01A8JHh9fRFxK2FeDQDxaECV
</commit_message>
<xml_diff>
--- a/docs/seminar/seminar-video-content.pptx
+++ b/docs/seminar/seminar-video-content.pptx
@@ -1694,7 +1694,7 @@
           <a:p>
             <a:r>
               <a:rPr lang="en-US" dirty="0"/>
-              <a:t>【48-63分】
+              <a:t>【54-69分】
 「最後のワークです。AIの上手な使い方より大事なのは、"どの業務からやるか"の見極めです。道具はもう体験しました。あとは当てる場所です」
 ▼マトリクスの説明は右上から。「よくあって、やり方が決まっている仕事。見積、日報、定型の返信。ここが最初です。理由は簡単で、回数が多いから効果が積み上がり、やり方が決まっているからAIが真似できる」
 ▼配布の仕分けシートに書き込んでもらう(10分)。机間巡視でシートを覗き、「その業務いいですね」と声かけ——この時間に各社の業務が見える(調査価値2回目のピーク)。
@@ -1874,7 +1874,7 @@
           <a:p>
             <a:r>
               <a:rPr lang="en-US" dirty="0"/>
-              <a:t>【63-70分】
+              <a:t>【69-76分】
 「ここから経営者としての整え方を2点だけ。効果測定とルールです」
 ▼左：「今日皆さんが体験した楽しさは、社員には伝わりません。伝わるのは数字だけです。だから最初の1業務は必ずビフォーの時間を測ってから始めてください」
 ▼右：「そして広げる前に線を引く。今日の会場ルール(社名を入れない)を思い出してください。あれが①の線引きです。残りは雛形に書いてあります。今日持ち帰って、自社名を入れるだけです」
@@ -2054,7 +2054,7 @@
           <a:p>
             <a:r>
               <a:rPr lang="en-US" dirty="0"/>
-              <a:t>【70-78分】
+              <a:t>【76-80分】
 「最後に、社員に広げる段階のお金の話です。実は、社員のAI研修には国の助成金が使えます。数字を3つだけ覚えて帰ってください。75%、時給1,000円、そして2027年3月31日」
 ▼期限の話を最初に強調：「この制度、来年度の3月で終わります。半年ちょっとです。私が今日この話をしているのは、知らずに期限を過ぎる会社が多すぎるからです」
 ▼正直さの演出（重要）：「申請するのは皆さんの会社から労働局へ、です。私は申請代行はできません——それは社労士さんの独占業務です。私にできるのは、制度を正確にお伝えすることと、研修そのものをお手伝いすることです」——この線引きを自分から言うと信頼が上がる。</a:t>
@@ -2145,7 +2145,7 @@
           <a:p>
             <a:r>
               <a:rPr lang="en-US" dirty="0"/>
-              <a:t>【78-81分】
+              <a:t>【80-83分】
 「具体的な金額で見てみます。社員10名、1人20万円の研修だと総額200万円。経費助成で150万円戻って実質50万円。さらに研修中の賃金助成が12万円ついて、最終的な負担は約38万円です」
 ▼一拍おいて：「200万円と38万円では、意思決定の重さが違います。制度が生きているうちに動くかどうか、だけの差です」
 ▼免責は必ず口頭でも：「金額はあくまで例で、支給は労働局の審査次第です。確実にもらえるとは言えません——ここは正直にお伝えします」</a:t>
@@ -2236,7 +2236,7 @@
           <a:p>
             <a:r>
               <a:rPr lang="en-US" dirty="0"/>
-              <a:t>【81-84分】
+              <a:t>【83-85分】
 「動くなら逆算です。計画届は研修開始の1か月前まで。制度終了が2027年3月末なので、逆算するともう悠長にはしていられません」
 ▼プラスワンの配布物2点をここで渡す：
 ①逆算カレンダー：「開始したい月から締切を逆算できる1枚です」
@@ -2329,7 +2329,7 @@
           <a:p>
             <a:r>
               <a:rPr lang="en-US" dirty="0"/>
-              <a:t>【84-87分】
+              <a:t>【85-88分】
 「今日は聞くだけのセミナーにしない、と最初にお約束しました。確認です。皆さんのスマホには、①自社の診断書、②明日使う実文書、そして配布シートには③最初の1業務、が残っています」
 ▼最後の刷り込み：「プロンプトは全部忘れて構いません。1つだけ、"いきなり書かせない、まず質問させる"。これだけ持ち帰ってください」
 ▼会場全体に成果があることを確認してからクロージングへ。</a:t>
@@ -2420,7 +2420,7 @@
           <a:p>
             <a:r>
               <a:rPr lang="en-US" dirty="0"/>
-              <a:t>【87-90分】
+              <a:t>【88-90分】
 「最後にご案内です。今日のワーク3で決めた"最初の1業務"、あの続きを、御社の実際の業務内容で一緒に仕上げる無料相談をやっています。30分です。ご希望の方はアンケートに○だけつけてください。こちらから日程のご連絡を差し上げます」
 ▼売り込まない。「研修」「契約」という言葉はここでは一切出さない。相談の場で、ワーク3のシートを見ながら自然に研修・伴走の話につなげる。
 ▼アンケート回収は出口で手渡し回収（回収率が倍変わる）。個別相談の○の数が、このセミナーのKPI。</a:t>
@@ -2961,7 +2961,7 @@
               <a:rPr lang="en-US" dirty="0"/>
               <a:t>【21-24分】
 「今のワークで感じていただいた通り、AIの正体は検索の親玉ではありません。壁打ち相手です」
-▼経営者の共感ポイントを突く：「経営の悩みって、社員には話せない。家族に話しても伝わらない。同業に話すのは怖い。そこに、深夜2時でも付き合ってくれて、口が堅くて、タダの相談相手が現れた——これが経営者にとっての生成AIです」
+▼経営者の共感ポイントを突く：「経営の悩みって、社員には話せない。家族に話しても伝わらない。同業に話すのは怖い。そこに、深夜2時でも付き合ってくれて、嫌な顔ひとつせず、タダの相談相手が現れた——これが経営者にとっての生成AIです。ただし話す内容は選ぶ。だから今日の、社名を入れないルールなんです」
 ▼ここは講義パートだが3分で切り上げ、すぐ次のワークへ。</a:t>
             </a:r>
             <a:endParaRPr lang="en-US" dirty="0"/>
@@ -6294,7 +6294,7 @@
                 <a:ea typeface="Yu Gothic" pitchFamily="34" charset="-122"/>
                 <a:cs typeface="Yu Gothic" pitchFamily="34" charset="-120"/>
               </a:rPr>
-              <a:t>毎朝の転記作業が、いまゼロになりました</a:t>
+              <a:t>毎朝の転記作業を、ゼロにできます</a:t>
             </a:r>
             <a:endParaRPr lang="en-US" sz="1800" dirty="0"/>
           </a:p>
@@ -8061,7 +8061,46 @@
       </p:sp>
       <p:sp>
         <p:nvSpPr>
-          <p:cNvPr id="6" name="Shape 3"/>
+          <p:cNvPr id="6" name="Text 3"/>
+          <p:cNvSpPr/>
+          <p:nvPr/>
+        </p:nvSpPr>
+        <p:spPr>
+          <a:xfrm>
+            <a:off x="548640" y="6126480"/>
+            <a:ext cx="11064240" cy="320040"/>
+          </a:xfrm>
+          <a:prstGeom prst="rect">
+            <a:avLst/>
+          </a:prstGeom>
+          <a:noFill/>
+          <a:ln/>
+        </p:spPr>
+        <p:txBody>
+          <a:bodyPr wrap="square" lIns="0" tIns="0" rIns="0" bIns="0" rtlCol="0" anchor="ctr"/>
+          <a:lstStyle/>
+          <a:p>
+            <a:pPr indent="0" marL="0">
+              <a:buNone/>
+            </a:pPr>
+            <a:r>
+              <a:rPr lang="en-US" sz="1100" dirty="0">
+                <a:solidFill>
+                  <a:srgbClr val="CADCFC"/>
+                </a:solidFill>
+                <a:latin typeface="Yu Gothic" pitchFamily="34" charset="0"/>
+                <a:ea typeface="Yu Gothic" pitchFamily="34" charset="-122"/>
+                <a:cs typeface="Yu Gothic" pitchFamily="34" charset="-120"/>
+              </a:rPr>
+              <a:t>使用ツール：Google NotebookLM（無料・Googleアカウントが必要）※今日は覚えなくてOK</a:t>
+            </a:r>
+            <a:endParaRPr lang="en-US" sz="1100" dirty="0"/>
+          </a:p>
+        </p:txBody>
+      </p:sp>
+      <p:sp>
+        <p:nvSpPr>
+          <p:cNvPr id="7" name="Shape 4"/>
           <p:cNvSpPr/>
           <p:nvPr/>
         </p:nvSpPr>
@@ -8083,7 +8122,7 @@
       </p:sp>
       <p:sp>
         <p:nvSpPr>
-          <p:cNvPr id="7" name="Text 4"/>
+          <p:cNvPr id="8" name="Text 5"/>
           <p:cNvSpPr/>
           <p:nvPr/>
         </p:nvSpPr>
@@ -13157,7 +13196,7 @@
                 <a:ea typeface="Yu Gothic" pitchFamily="34" charset="-122"/>
                 <a:cs typeface="Yu Gothic" pitchFamily="34" charset="-120"/>
               </a:rPr>
-              <a:t>※ 対象は10時間以上の訓練など要件があります。支給決定は労働局の審査によります</a:t>
+              <a:t>※ 2026年7月時点の制度情報です（1人あたり上限額など要件あり）。最新は厚生労働省サイトでご確認ください</a:t>
             </a:r>
             <a:endParaRPr lang="en-US" sz="1150" dirty="0"/>
           </a:p>
@@ -13253,7 +13292,7 @@
                 <a:gridCol w="6035040"/>
                 <a:gridCol w="3200400"/>
               </a:tblGrid>
-              <a:tr h="566928">
+              <a:tr h="475488">
                 <a:tc>
                   <a:txBody>
                     <a:bodyPr/>
@@ -13391,7 +13430,7 @@
                   </a:tcPr>
                 </a:tc>
               </a:tr>
-              <a:tr h="566928">
+              <a:tr h="475488">
                 <a:tc>
                   <a:txBody>
                     <a:bodyPr/>
@@ -13529,7 +13568,7 @@
                   </a:tcPr>
                 </a:tc>
               </a:tr>
-              <a:tr h="566928">
+              <a:tr h="475488">
                 <a:tc>
                   <a:txBody>
                     <a:bodyPr/>
@@ -13667,7 +13706,7 @@
                   </a:tcPr>
                 </a:tc>
               </a:tr>
-              <a:tr h="566928">
+              <a:tr h="475488">
                 <a:tc>
                   <a:txBody>
                     <a:bodyPr/>
@@ -13805,7 +13844,7 @@
                   </a:tcPr>
                 </a:tc>
               </a:tr>
-              <a:tr h="566928">
+              <a:tr h="475488">
                 <a:tc>
                   <a:txBody>
                     <a:bodyPr/>
@@ -13943,7 +13982,7 @@
                   </a:tcPr>
                 </a:tc>
               </a:tr>
-              <a:tr h="566928">
+              <a:tr h="475488">
                 <a:tc>
                   <a:txBody>
                     <a:bodyPr/>
@@ -14081,6 +14120,144 @@
                   </a:tcPr>
                 </a:tc>
               </a:tr>
+              <a:tr h="475488">
+                <a:tc>
+                  <a:txBody>
+                    <a:bodyPr/>
+                    <a:lstStyle/>
+                    <a:p>
+                      <a:pPr indent="0" marL="0">
+                        <a:buNone/>
+                      </a:pPr>
+                      <a:r>
+                        <a:rPr lang="en-US" sz="1500" dirty="0">
+                          <a:solidFill>
+                            <a:srgbClr val="333333"/>
+                          </a:solidFill>
+                          <a:latin typeface="Yu Gothic" pitchFamily="34" charset="0"/>
+                          <a:ea typeface="Yu Gothic" pitchFamily="34" charset="-122"/>
+                          <a:cs typeface="Yu Gothic" pitchFamily="34" charset="-120"/>
+                        </a:rPr>
+                        <a:t>参考：社員3名なら（20万円 × 3名 ＝ 60万円）</a:t>
+                      </a:r>
+                      <a:endParaRPr lang="en-US" sz="1500" dirty="0">
+                        <a:latin typeface="Yu Gothic" charset="0"/>
+                        <a:ea typeface="Yu Gothic" charset="0"/>
+                        <a:cs typeface="Yu Gothic" charset="0"/>
+                      </a:endParaRPr>
+                    </a:p>
+                  </a:txBody>
+                  <a:tcPr marL="109728" marR="109728" marT="109728" marB="109728" anchor="ctr">
+                    <a:lnL w="12700" cap="flat" cmpd="sng" algn="ctr">
+                      <a:solidFill>
+                        <a:srgbClr val="D5DEF0"/>
+                      </a:solidFill>
+                      <a:prstDash val="solid"/>
+                      <a:round/>
+                      <a:headEnd type="none" w="med" len="med"/>
+                      <a:tailEnd type="none" w="med" len="med"/>
+                    </a:lnL>
+                    <a:lnR w="12700" cap="flat" cmpd="sng" algn="ctr">
+                      <a:solidFill>
+                        <a:srgbClr val="D5DEF0"/>
+                      </a:solidFill>
+                      <a:prstDash val="solid"/>
+                      <a:round/>
+                      <a:headEnd type="none" w="med" len="med"/>
+                      <a:tailEnd type="none" w="med" len="med"/>
+                    </a:lnR>
+                    <a:lnT w="12700" cap="flat" cmpd="sng" algn="ctr">
+                      <a:solidFill>
+                        <a:srgbClr val="D5DEF0"/>
+                      </a:solidFill>
+                      <a:prstDash val="solid"/>
+                      <a:round/>
+                      <a:headEnd type="none" w="med" len="med"/>
+                      <a:tailEnd type="none" w="med" len="med"/>
+                    </a:lnT>
+                    <a:lnB w="12700" cap="flat" cmpd="sng" algn="ctr">
+                      <a:solidFill>
+                        <a:srgbClr val="D5DEF0"/>
+                      </a:solidFill>
+                      <a:prstDash val="solid"/>
+                      <a:round/>
+                      <a:headEnd type="none" w="med" len="med"/>
+                      <a:tailEnd type="none" w="med" len="med"/>
+                    </a:lnB>
+                    <a:solidFill>
+                      <a:srgbClr val="FFFFFF"/>
+                    </a:solidFill>
+                  </a:tcPr>
+                </a:tc>
+                <a:tc>
+                  <a:txBody>
+                    <a:bodyPr/>
+                    <a:lstStyle/>
+                    <a:p>
+                      <a:pPr indent="0" marL="0">
+                        <a:buNone/>
+                      </a:pPr>
+                      <a:r>
+                        <a:rPr lang="en-US" sz="1500" dirty="0">
+                          <a:solidFill>
+                            <a:srgbClr val="333333"/>
+                          </a:solidFill>
+                          <a:latin typeface="Yu Gothic" pitchFamily="34" charset="0"/>
+                          <a:ea typeface="Yu Gothic" pitchFamily="34" charset="-122"/>
+                          <a:cs typeface="Yu Gothic" pitchFamily="34" charset="-120"/>
+                        </a:rPr>
+                        <a:t>実質 約11万円</a:t>
+                      </a:r>
+                      <a:endParaRPr lang="en-US" sz="1500" dirty="0">
+                        <a:latin typeface="Yu Gothic" charset="0"/>
+                        <a:ea typeface="Yu Gothic" charset="0"/>
+                        <a:cs typeface="Yu Gothic" charset="0"/>
+                      </a:endParaRPr>
+                    </a:p>
+                  </a:txBody>
+                  <a:tcPr marL="109728" marR="109728" marT="109728" marB="109728" anchor="ctr">
+                    <a:lnL w="12700" cap="flat" cmpd="sng" algn="ctr">
+                      <a:solidFill>
+                        <a:srgbClr val="D5DEF0"/>
+                      </a:solidFill>
+                      <a:prstDash val="solid"/>
+                      <a:round/>
+                      <a:headEnd type="none" w="med" len="med"/>
+                      <a:tailEnd type="none" w="med" len="med"/>
+                    </a:lnL>
+                    <a:lnR w="12700" cap="flat" cmpd="sng" algn="ctr">
+                      <a:solidFill>
+                        <a:srgbClr val="D5DEF0"/>
+                      </a:solidFill>
+                      <a:prstDash val="solid"/>
+                      <a:round/>
+                      <a:headEnd type="none" w="med" len="med"/>
+                      <a:tailEnd type="none" w="med" len="med"/>
+                    </a:lnR>
+                    <a:lnT w="12700" cap="flat" cmpd="sng" algn="ctr">
+                      <a:solidFill>
+                        <a:srgbClr val="D5DEF0"/>
+                      </a:solidFill>
+                      <a:prstDash val="solid"/>
+                      <a:round/>
+                      <a:headEnd type="none" w="med" len="med"/>
+                      <a:tailEnd type="none" w="med" len="med"/>
+                    </a:lnT>
+                    <a:lnB w="12700" cap="flat" cmpd="sng" algn="ctr">
+                      <a:solidFill>
+                        <a:srgbClr val="D5DEF0"/>
+                      </a:solidFill>
+                      <a:prstDash val="solid"/>
+                      <a:round/>
+                      <a:headEnd type="none" w="med" len="med"/>
+                      <a:tailEnd type="none" w="med" len="med"/>
+                    </a:lnB>
+                    <a:solidFill>
+                      <a:srgbClr val="FFFFFF"/>
+                    </a:solidFill>
+                  </a:tcPr>
+                </a:tc>
+              </a:tr>
             </a:tbl>
           </a:graphicData>
         </a:graphic>
@@ -14140,7 +14317,7 @@
                 <a:ea typeface="Yu Gothic" pitchFamily="34" charset="-122"/>
                 <a:cs typeface="Yu Gothic" pitchFamily="34" charset="-120"/>
               </a:rPr>
-              <a:t>200万円の投資判断は重い。約38万円なら、今日決められる</a:t>
+              <a:t>200万円は重い。約38万円は、検討を今日始められる数字ではないでしょうか</a:t>
             </a:r>
             <a:endParaRPr lang="en-US" sz="1500" dirty="0"/>
           </a:p>
@@ -14179,7 +14356,7 @@
                 <a:ea typeface="Yu Gothic" pitchFamily="34" charset="-122"/>
                 <a:cs typeface="Yu Gothic" pitchFamily="34" charset="-120"/>
               </a:rPr>
-              <a:t>※ 金額は例。申請は貴社から労働局へ。支給決定は審査によります。申請手続きの代行は行いません（社会保険労務士の業務）</a:t>
+              <a:t>※ 金額は例。対象は雇用保険加入の従業員（経費助成には1人あたり上限額あり）。申請は貴社から労働局へ行い、支給決定は審査によります。申請代行は行いません（社会保険労務士の業務）</a:t>
             </a:r>
             <a:endParaRPr lang="en-US" sz="1100" dirty="0"/>
           </a:p>
@@ -16826,6 +17003,45 @@
               <a:t>※ すでに入っている方は、隣の方のセットアップを手伝ってあげてください</a:t>
             </a:r>
             <a:endParaRPr lang="en-US" sz="1200" dirty="0"/>
+          </a:p>
+        </p:txBody>
+      </p:sp>
+      <p:sp>
+        <p:nvSpPr>
+          <p:cNvPr id="19" name="Text 16"/>
+          <p:cNvSpPr/>
+          <p:nvPr/>
+        </p:nvSpPr>
+        <p:spPr>
+          <a:xfrm>
+            <a:off x="822960" y="5760720"/>
+            <a:ext cx="10789920" cy="411480"/>
+          </a:xfrm>
+          <a:prstGeom prst="rect">
+            <a:avLst/>
+          </a:prstGeom>
+          <a:noFill/>
+          <a:ln/>
+        </p:spPr>
+        <p:txBody>
+          <a:bodyPr wrap="square" lIns="0" tIns="0" rIns="0" bIns="0" rtlCol="0" anchor="ctr"/>
+          <a:lstStyle/>
+          <a:p>
+            <a:pPr indent="0" marL="0">
+              <a:buNone/>
+            </a:pPr>
+            <a:r>
+              <a:rPr lang="en-US" sz="1300" b="1" dirty="0">
+                <a:solidFill>
+                  <a:srgbClr val="1E2761"/>
+                </a:solidFill>
+                <a:latin typeface="Yu Gothic" pitchFamily="34" charset="0"/>
+                <a:ea typeface="Yu Gothic" pitchFamily="34" charset="-122"/>
+                <a:cs typeface="Yu Gothic" pitchFamily="34" charset="-120"/>
+              </a:rPr>
+              <a:t>入力が大変な方へ：キーボードのマイクボタンで「話すだけ入力」ができます　※無料版は回数制限あり。出たら少し待てばOK</a:t>
+            </a:r>
+            <a:endParaRPr lang="en-US" sz="1300" dirty="0"/>
           </a:p>
         </p:txBody>
       </p:sp>

</xml_diff>